<commit_message>
update crewai not good for coding.
</commit_message>
<xml_diff>
--- a/wj_folder/AI Engineer Agentic Track.pptx
+++ b/wj_folder/AI Engineer Agentic Track.pptx
@@ -93,6 +93,7 @@
     <p:sldId id="343" r:id="rId87"/>
     <p:sldId id="344" r:id="rId88"/>
     <p:sldId id="345" r:id="rId89"/>
+    <p:sldId id="346" r:id="rId90"/>
   </p:sldIdLst>
   <p:sldSz cx="12192000" cy="6858000"/>
   <p:notesSz cx="6858000" cy="9144000"/>
@@ -193,7 +194,7 @@
   </p:defaultTextStyle>
   <p:extLst>
     <p:ext uri="{EFAFB233-063F-42B5-8137-9DF3F51BA10A}">
-      <p15:sldGuideLst xmlns="" xmlns:p15="http://schemas.microsoft.com/office/powerpoint/2012/main"/>
+      <p15:sldGuideLst xmlns:p15="http://schemas.microsoft.com/office/powerpoint/2012/main" xmlns=""/>
     </p:ext>
   </p:extLst>
 </p:presentation>
@@ -221,7 +222,7 @@
           <p:cNvPr id="2" name="Title 1">
             <a:extLst>
               <a:ext uri="{FF2B5EF4-FFF2-40B4-BE49-F238E27FC236}">
-                <a16:creationId xmlns="" xmlns:a16="http://schemas.microsoft.com/office/drawing/2014/main" id="{35B3E28E-18CE-48AC-B6DC-8A8656CDEDB7}"/>
+                <a16:creationId xmlns:a16="http://schemas.microsoft.com/office/drawing/2014/main" xmlns="" id="{35B3E28E-18CE-48AC-B6DC-8A8656CDEDB7}"/>
               </a:ext>
             </a:extLst>
           </p:cNvPr>
@@ -259,7 +260,7 @@
           <p:cNvPr id="3" name="Subtitle 2">
             <a:extLst>
               <a:ext uri="{FF2B5EF4-FFF2-40B4-BE49-F238E27FC236}">
-                <a16:creationId xmlns="" xmlns:a16="http://schemas.microsoft.com/office/drawing/2014/main" id="{2B6A52DD-2FAB-4A70-B6D2-95F094A8B4BF}"/>
+                <a16:creationId xmlns:a16="http://schemas.microsoft.com/office/drawing/2014/main" xmlns="" id="{2B6A52DD-2FAB-4A70-B6D2-95F094A8B4BF}"/>
               </a:ext>
             </a:extLst>
           </p:cNvPr>
@@ -330,7 +331,7 @@
           <p:cNvPr id="4" name="Date Placeholder 3">
             <a:extLst>
               <a:ext uri="{FF2B5EF4-FFF2-40B4-BE49-F238E27FC236}">
-                <a16:creationId xmlns="" xmlns:a16="http://schemas.microsoft.com/office/drawing/2014/main" id="{04BAD745-F79C-4969-B66B-32EAF85AEB5D}"/>
+                <a16:creationId xmlns:a16="http://schemas.microsoft.com/office/drawing/2014/main" xmlns="" id="{04BAD745-F79C-4969-B66B-32EAF85AEB5D}"/>
               </a:ext>
             </a:extLst>
           </p:cNvPr>
@@ -360,7 +361,7 @@
           <p:cNvPr id="5" name="Footer Placeholder 4">
             <a:extLst>
               <a:ext uri="{FF2B5EF4-FFF2-40B4-BE49-F238E27FC236}">
-                <a16:creationId xmlns="" xmlns:a16="http://schemas.microsoft.com/office/drawing/2014/main" id="{1C786EE0-F04B-4BBE-8583-F02BC47C4ADC}"/>
+                <a16:creationId xmlns:a16="http://schemas.microsoft.com/office/drawing/2014/main" xmlns="" id="{1C786EE0-F04B-4BBE-8583-F02BC47C4ADC}"/>
               </a:ext>
             </a:extLst>
           </p:cNvPr>
@@ -385,7 +386,7 @@
           <p:cNvPr id="6" name="Slide Number Placeholder 5">
             <a:extLst>
               <a:ext uri="{FF2B5EF4-FFF2-40B4-BE49-F238E27FC236}">
-                <a16:creationId xmlns="" xmlns:a16="http://schemas.microsoft.com/office/drawing/2014/main" id="{9A99FA26-9A64-457F-8D29-D065353FF9F0}"/>
+                <a16:creationId xmlns:a16="http://schemas.microsoft.com/office/drawing/2014/main" xmlns="" id="{9A99FA26-9A64-457F-8D29-D065353FF9F0}"/>
               </a:ext>
             </a:extLst>
           </p:cNvPr>
@@ -413,7 +414,7 @@
     </p:spTree>
     <p:extLst>
       <p:ext uri="{BB962C8B-B14F-4D97-AF65-F5344CB8AC3E}">
-        <p14:creationId xmlns="" xmlns:p14="http://schemas.microsoft.com/office/powerpoint/2010/main" val="2667922328"/>
+        <p14:creationId xmlns:p14="http://schemas.microsoft.com/office/powerpoint/2010/main" xmlns="" val="2667922328"/>
       </p:ext>
     </p:extLst>
   </p:cSld>
@@ -445,7 +446,7 @@
           <p:cNvPr id="2" name="Title 1">
             <a:extLst>
               <a:ext uri="{FF2B5EF4-FFF2-40B4-BE49-F238E27FC236}">
-                <a16:creationId xmlns="" xmlns:a16="http://schemas.microsoft.com/office/drawing/2014/main" id="{3AAA867B-006D-4CFD-B0EC-6278F9C6F395}"/>
+                <a16:creationId xmlns:a16="http://schemas.microsoft.com/office/drawing/2014/main" xmlns="" id="{3AAA867B-006D-4CFD-B0EC-6278F9C6F395}"/>
               </a:ext>
             </a:extLst>
           </p:cNvPr>
@@ -474,7 +475,7 @@
           <p:cNvPr id="3" name="Vertical Text Placeholder 2">
             <a:extLst>
               <a:ext uri="{FF2B5EF4-FFF2-40B4-BE49-F238E27FC236}">
-                <a16:creationId xmlns="" xmlns:a16="http://schemas.microsoft.com/office/drawing/2014/main" id="{6B68286A-F7B1-4E68-85D2-589B8E6EB3D0}"/>
+                <a16:creationId xmlns:a16="http://schemas.microsoft.com/office/drawing/2014/main" xmlns="" id="{6B68286A-F7B1-4E68-85D2-589B8E6EB3D0}"/>
               </a:ext>
             </a:extLst>
           </p:cNvPr>
@@ -532,7 +533,7 @@
           <p:cNvPr id="4" name="Date Placeholder 3">
             <a:extLst>
               <a:ext uri="{FF2B5EF4-FFF2-40B4-BE49-F238E27FC236}">
-                <a16:creationId xmlns="" xmlns:a16="http://schemas.microsoft.com/office/drawing/2014/main" id="{0ABE87C5-816E-492F-A0B6-37580D37F936}"/>
+                <a16:creationId xmlns:a16="http://schemas.microsoft.com/office/drawing/2014/main" xmlns="" id="{0ABE87C5-816E-492F-A0B6-37580D37F936}"/>
               </a:ext>
             </a:extLst>
           </p:cNvPr>
@@ -562,7 +563,7 @@
           <p:cNvPr id="5" name="Footer Placeholder 4">
             <a:extLst>
               <a:ext uri="{FF2B5EF4-FFF2-40B4-BE49-F238E27FC236}">
-                <a16:creationId xmlns="" xmlns:a16="http://schemas.microsoft.com/office/drawing/2014/main" id="{CCCB506B-7592-40AA-96EF-65E8E107D9C8}"/>
+                <a16:creationId xmlns:a16="http://schemas.microsoft.com/office/drawing/2014/main" xmlns="" id="{CCCB506B-7592-40AA-96EF-65E8E107D9C8}"/>
               </a:ext>
             </a:extLst>
           </p:cNvPr>
@@ -587,7 +588,7 @@
           <p:cNvPr id="6" name="Slide Number Placeholder 5">
             <a:extLst>
               <a:ext uri="{FF2B5EF4-FFF2-40B4-BE49-F238E27FC236}">
-                <a16:creationId xmlns="" xmlns:a16="http://schemas.microsoft.com/office/drawing/2014/main" id="{60B3A27B-7FBB-4800-A8DA-288A2A7FA3B4}"/>
+                <a16:creationId xmlns:a16="http://schemas.microsoft.com/office/drawing/2014/main" xmlns="" id="{60B3A27B-7FBB-4800-A8DA-288A2A7FA3B4}"/>
               </a:ext>
             </a:extLst>
           </p:cNvPr>
@@ -615,7 +616,7 @@
     </p:spTree>
     <p:extLst>
       <p:ext uri="{BB962C8B-B14F-4D97-AF65-F5344CB8AC3E}">
-        <p14:creationId xmlns="" xmlns:p14="http://schemas.microsoft.com/office/powerpoint/2010/main" val="1789993025"/>
+        <p14:creationId xmlns:p14="http://schemas.microsoft.com/office/powerpoint/2010/main" xmlns="" val="1789993025"/>
       </p:ext>
     </p:extLst>
   </p:cSld>
@@ -647,7 +648,7 @@
           <p:cNvPr id="2" name="Vertical Title 1">
             <a:extLst>
               <a:ext uri="{FF2B5EF4-FFF2-40B4-BE49-F238E27FC236}">
-                <a16:creationId xmlns="" xmlns:a16="http://schemas.microsoft.com/office/drawing/2014/main" id="{E3CAE2E0-E6B1-495D-AC76-5924F353B30B}"/>
+                <a16:creationId xmlns:a16="http://schemas.microsoft.com/office/drawing/2014/main" xmlns="" id="{E3CAE2E0-E6B1-495D-AC76-5924F353B30B}"/>
               </a:ext>
             </a:extLst>
           </p:cNvPr>
@@ -681,7 +682,7 @@
           <p:cNvPr id="3" name="Vertical Text Placeholder 2">
             <a:extLst>
               <a:ext uri="{FF2B5EF4-FFF2-40B4-BE49-F238E27FC236}">
-                <a16:creationId xmlns="" xmlns:a16="http://schemas.microsoft.com/office/drawing/2014/main" id="{14D381DB-6117-4A94-B30D-F35754825875}"/>
+                <a16:creationId xmlns:a16="http://schemas.microsoft.com/office/drawing/2014/main" xmlns="" id="{14D381DB-6117-4A94-B30D-F35754825875}"/>
               </a:ext>
             </a:extLst>
           </p:cNvPr>
@@ -744,7 +745,7 @@
           <p:cNvPr id="4" name="Date Placeholder 3">
             <a:extLst>
               <a:ext uri="{FF2B5EF4-FFF2-40B4-BE49-F238E27FC236}">
-                <a16:creationId xmlns="" xmlns:a16="http://schemas.microsoft.com/office/drawing/2014/main" id="{D9F0CC51-792E-4BE0-B368-1BAD7EC3054B}"/>
+                <a16:creationId xmlns:a16="http://schemas.microsoft.com/office/drawing/2014/main" xmlns="" id="{D9F0CC51-792E-4BE0-B368-1BAD7EC3054B}"/>
               </a:ext>
             </a:extLst>
           </p:cNvPr>
@@ -774,7 +775,7 @@
           <p:cNvPr id="5" name="Footer Placeholder 4">
             <a:extLst>
               <a:ext uri="{FF2B5EF4-FFF2-40B4-BE49-F238E27FC236}">
-                <a16:creationId xmlns="" xmlns:a16="http://schemas.microsoft.com/office/drawing/2014/main" id="{671D2F8B-58E9-4E4B-BAE5-CFEBD5297B5F}"/>
+                <a16:creationId xmlns:a16="http://schemas.microsoft.com/office/drawing/2014/main" xmlns="" id="{671D2F8B-58E9-4E4B-BAE5-CFEBD5297B5F}"/>
               </a:ext>
             </a:extLst>
           </p:cNvPr>
@@ -799,7 +800,7 @@
           <p:cNvPr id="6" name="Slide Number Placeholder 5">
             <a:extLst>
               <a:ext uri="{FF2B5EF4-FFF2-40B4-BE49-F238E27FC236}">
-                <a16:creationId xmlns="" xmlns:a16="http://schemas.microsoft.com/office/drawing/2014/main" id="{B7291426-4EDB-4891-B650-32D85684F47B}"/>
+                <a16:creationId xmlns:a16="http://schemas.microsoft.com/office/drawing/2014/main" xmlns="" id="{B7291426-4EDB-4891-B650-32D85684F47B}"/>
               </a:ext>
             </a:extLst>
           </p:cNvPr>
@@ -827,7 +828,7 @@
     </p:spTree>
     <p:extLst>
       <p:ext uri="{BB962C8B-B14F-4D97-AF65-F5344CB8AC3E}">
-        <p14:creationId xmlns="" xmlns:p14="http://schemas.microsoft.com/office/powerpoint/2010/main" val="2264661611"/>
+        <p14:creationId xmlns:p14="http://schemas.microsoft.com/office/powerpoint/2010/main" xmlns="" val="2264661611"/>
       </p:ext>
     </p:extLst>
   </p:cSld>
@@ -859,7 +860,7 @@
           <p:cNvPr id="2" name="Title 1">
             <a:extLst>
               <a:ext uri="{FF2B5EF4-FFF2-40B4-BE49-F238E27FC236}">
-                <a16:creationId xmlns="" xmlns:a16="http://schemas.microsoft.com/office/drawing/2014/main" id="{B55AF50E-259D-4420-9188-F51DD2BAFD70}"/>
+                <a16:creationId xmlns:a16="http://schemas.microsoft.com/office/drawing/2014/main" xmlns="" id="{B55AF50E-259D-4420-9188-F51DD2BAFD70}"/>
               </a:ext>
             </a:extLst>
           </p:cNvPr>
@@ -888,7 +889,7 @@
           <p:cNvPr id="3" name="Content Placeholder 2">
             <a:extLst>
               <a:ext uri="{FF2B5EF4-FFF2-40B4-BE49-F238E27FC236}">
-                <a16:creationId xmlns="" xmlns:a16="http://schemas.microsoft.com/office/drawing/2014/main" id="{A73F7E3F-7470-4510-A780-183E65AC186B}"/>
+                <a16:creationId xmlns:a16="http://schemas.microsoft.com/office/drawing/2014/main" xmlns="" id="{A73F7E3F-7470-4510-A780-183E65AC186B}"/>
               </a:ext>
             </a:extLst>
           </p:cNvPr>
@@ -946,7 +947,7 @@
           <p:cNvPr id="4" name="Date Placeholder 3">
             <a:extLst>
               <a:ext uri="{FF2B5EF4-FFF2-40B4-BE49-F238E27FC236}">
-                <a16:creationId xmlns="" xmlns:a16="http://schemas.microsoft.com/office/drawing/2014/main" id="{A54D4AD1-EA5B-4614-A5E6-D63FC76F3576}"/>
+                <a16:creationId xmlns:a16="http://schemas.microsoft.com/office/drawing/2014/main" xmlns="" id="{A54D4AD1-EA5B-4614-A5E6-D63FC76F3576}"/>
               </a:ext>
             </a:extLst>
           </p:cNvPr>
@@ -976,7 +977,7 @@
           <p:cNvPr id="5" name="Footer Placeholder 4">
             <a:extLst>
               <a:ext uri="{FF2B5EF4-FFF2-40B4-BE49-F238E27FC236}">
-                <a16:creationId xmlns="" xmlns:a16="http://schemas.microsoft.com/office/drawing/2014/main" id="{718FB14E-3AD2-47F4-A1D1-E1C9AC988571}"/>
+                <a16:creationId xmlns:a16="http://schemas.microsoft.com/office/drawing/2014/main" xmlns="" id="{718FB14E-3AD2-47F4-A1D1-E1C9AC988571}"/>
               </a:ext>
             </a:extLst>
           </p:cNvPr>
@@ -1001,7 +1002,7 @@
           <p:cNvPr id="6" name="Slide Number Placeholder 5">
             <a:extLst>
               <a:ext uri="{FF2B5EF4-FFF2-40B4-BE49-F238E27FC236}">
-                <a16:creationId xmlns="" xmlns:a16="http://schemas.microsoft.com/office/drawing/2014/main" id="{A17876F6-21A2-4792-B530-0A93D3DBC805}"/>
+                <a16:creationId xmlns:a16="http://schemas.microsoft.com/office/drawing/2014/main" xmlns="" id="{A17876F6-21A2-4792-B530-0A93D3DBC805}"/>
               </a:ext>
             </a:extLst>
           </p:cNvPr>
@@ -1029,7 +1030,7 @@
     </p:spTree>
     <p:extLst>
       <p:ext uri="{BB962C8B-B14F-4D97-AF65-F5344CB8AC3E}">
-        <p14:creationId xmlns="" xmlns:p14="http://schemas.microsoft.com/office/powerpoint/2010/main" val="2993451906"/>
+        <p14:creationId xmlns:p14="http://schemas.microsoft.com/office/powerpoint/2010/main" xmlns="" val="2993451906"/>
       </p:ext>
     </p:extLst>
   </p:cSld>
@@ -1061,7 +1062,7 @@
           <p:cNvPr id="2" name="Title 1">
             <a:extLst>
               <a:ext uri="{FF2B5EF4-FFF2-40B4-BE49-F238E27FC236}">
-                <a16:creationId xmlns="" xmlns:a16="http://schemas.microsoft.com/office/drawing/2014/main" id="{56B6865F-0872-4848-9520-4A864C60242A}"/>
+                <a16:creationId xmlns:a16="http://schemas.microsoft.com/office/drawing/2014/main" xmlns="" id="{56B6865F-0872-4848-9520-4A864C60242A}"/>
               </a:ext>
             </a:extLst>
           </p:cNvPr>
@@ -1099,7 +1100,7 @@
           <p:cNvPr id="3" name="Text Placeholder 2">
             <a:extLst>
               <a:ext uri="{FF2B5EF4-FFF2-40B4-BE49-F238E27FC236}">
-                <a16:creationId xmlns="" xmlns:a16="http://schemas.microsoft.com/office/drawing/2014/main" id="{F0AC7D33-E69A-4B17-A1A3-EE468AAB63BC}"/>
+                <a16:creationId xmlns:a16="http://schemas.microsoft.com/office/drawing/2014/main" xmlns="" id="{F0AC7D33-E69A-4B17-A1A3-EE468AAB63BC}"/>
               </a:ext>
             </a:extLst>
           </p:cNvPr>
@@ -1224,7 +1225,7 @@
           <p:cNvPr id="4" name="Date Placeholder 3">
             <a:extLst>
               <a:ext uri="{FF2B5EF4-FFF2-40B4-BE49-F238E27FC236}">
-                <a16:creationId xmlns="" xmlns:a16="http://schemas.microsoft.com/office/drawing/2014/main" id="{072E0E53-7128-4B7B-A804-96C3DFBB3B3D}"/>
+                <a16:creationId xmlns:a16="http://schemas.microsoft.com/office/drawing/2014/main" xmlns="" id="{072E0E53-7128-4B7B-A804-96C3DFBB3B3D}"/>
               </a:ext>
             </a:extLst>
           </p:cNvPr>
@@ -1254,7 +1255,7 @@
           <p:cNvPr id="5" name="Footer Placeholder 4">
             <a:extLst>
               <a:ext uri="{FF2B5EF4-FFF2-40B4-BE49-F238E27FC236}">
-                <a16:creationId xmlns="" xmlns:a16="http://schemas.microsoft.com/office/drawing/2014/main" id="{5B6BECC3-1CCF-43E3-958B-064CE362C516}"/>
+                <a16:creationId xmlns:a16="http://schemas.microsoft.com/office/drawing/2014/main" xmlns="" id="{5B6BECC3-1CCF-43E3-958B-064CE362C516}"/>
               </a:ext>
             </a:extLst>
           </p:cNvPr>
@@ -1279,7 +1280,7 @@
           <p:cNvPr id="6" name="Slide Number Placeholder 5">
             <a:extLst>
               <a:ext uri="{FF2B5EF4-FFF2-40B4-BE49-F238E27FC236}">
-                <a16:creationId xmlns="" xmlns:a16="http://schemas.microsoft.com/office/drawing/2014/main" id="{120A9F1B-A0D5-4299-91F8-A52B32E0FC0F}"/>
+                <a16:creationId xmlns:a16="http://schemas.microsoft.com/office/drawing/2014/main" xmlns="" id="{120A9F1B-A0D5-4299-91F8-A52B32E0FC0F}"/>
               </a:ext>
             </a:extLst>
           </p:cNvPr>
@@ -1307,7 +1308,7 @@
     </p:spTree>
     <p:extLst>
       <p:ext uri="{BB962C8B-B14F-4D97-AF65-F5344CB8AC3E}">
-        <p14:creationId xmlns="" xmlns:p14="http://schemas.microsoft.com/office/powerpoint/2010/main" val="3959936095"/>
+        <p14:creationId xmlns:p14="http://schemas.microsoft.com/office/powerpoint/2010/main" xmlns="" val="3959936095"/>
       </p:ext>
     </p:extLst>
   </p:cSld>
@@ -1339,7 +1340,7 @@
           <p:cNvPr id="2" name="Title 1">
             <a:extLst>
               <a:ext uri="{FF2B5EF4-FFF2-40B4-BE49-F238E27FC236}">
-                <a16:creationId xmlns="" xmlns:a16="http://schemas.microsoft.com/office/drawing/2014/main" id="{8F9F2B6E-2A11-419C-9C74-50A409504119}"/>
+                <a16:creationId xmlns:a16="http://schemas.microsoft.com/office/drawing/2014/main" xmlns="" id="{8F9F2B6E-2A11-419C-9C74-50A409504119}"/>
               </a:ext>
             </a:extLst>
           </p:cNvPr>
@@ -1368,7 +1369,7 @@
           <p:cNvPr id="3" name="Content Placeholder 2">
             <a:extLst>
               <a:ext uri="{FF2B5EF4-FFF2-40B4-BE49-F238E27FC236}">
-                <a16:creationId xmlns="" xmlns:a16="http://schemas.microsoft.com/office/drawing/2014/main" id="{D4E0461F-DECA-4D9E-B39B-D63502553258}"/>
+                <a16:creationId xmlns:a16="http://schemas.microsoft.com/office/drawing/2014/main" xmlns="" id="{D4E0461F-DECA-4D9E-B39B-D63502553258}"/>
               </a:ext>
             </a:extLst>
           </p:cNvPr>
@@ -1431,7 +1432,7 @@
           <p:cNvPr id="4" name="Content Placeholder 3">
             <a:extLst>
               <a:ext uri="{FF2B5EF4-FFF2-40B4-BE49-F238E27FC236}">
-                <a16:creationId xmlns="" xmlns:a16="http://schemas.microsoft.com/office/drawing/2014/main" id="{ED21C229-1E37-4349-B92D-45D802796487}"/>
+                <a16:creationId xmlns:a16="http://schemas.microsoft.com/office/drawing/2014/main" xmlns="" id="{ED21C229-1E37-4349-B92D-45D802796487}"/>
               </a:ext>
             </a:extLst>
           </p:cNvPr>
@@ -1494,7 +1495,7 @@
           <p:cNvPr id="5" name="Date Placeholder 4">
             <a:extLst>
               <a:ext uri="{FF2B5EF4-FFF2-40B4-BE49-F238E27FC236}">
-                <a16:creationId xmlns="" xmlns:a16="http://schemas.microsoft.com/office/drawing/2014/main" id="{9CF20FF1-9E73-47C2-841C-37A7861B813B}"/>
+                <a16:creationId xmlns:a16="http://schemas.microsoft.com/office/drawing/2014/main" xmlns="" id="{9CF20FF1-9E73-47C2-841C-37A7861B813B}"/>
               </a:ext>
             </a:extLst>
           </p:cNvPr>
@@ -1524,7 +1525,7 @@
           <p:cNvPr id="6" name="Footer Placeholder 5">
             <a:extLst>
               <a:ext uri="{FF2B5EF4-FFF2-40B4-BE49-F238E27FC236}">
-                <a16:creationId xmlns="" xmlns:a16="http://schemas.microsoft.com/office/drawing/2014/main" id="{2F30EA0D-F4E5-4D2C-A310-EBF53519CA8C}"/>
+                <a16:creationId xmlns:a16="http://schemas.microsoft.com/office/drawing/2014/main" xmlns="" id="{2F30EA0D-F4E5-4D2C-A310-EBF53519CA8C}"/>
               </a:ext>
             </a:extLst>
           </p:cNvPr>
@@ -1549,7 +1550,7 @@
           <p:cNvPr id="7" name="Slide Number Placeholder 6">
             <a:extLst>
               <a:ext uri="{FF2B5EF4-FFF2-40B4-BE49-F238E27FC236}">
-                <a16:creationId xmlns="" xmlns:a16="http://schemas.microsoft.com/office/drawing/2014/main" id="{CF787CF5-3FEA-4D0A-9F31-87D4A8BFAFF3}"/>
+                <a16:creationId xmlns:a16="http://schemas.microsoft.com/office/drawing/2014/main" xmlns="" id="{CF787CF5-3FEA-4D0A-9F31-87D4A8BFAFF3}"/>
               </a:ext>
             </a:extLst>
           </p:cNvPr>
@@ -1577,7 +1578,7 @@
     </p:spTree>
     <p:extLst>
       <p:ext uri="{BB962C8B-B14F-4D97-AF65-F5344CB8AC3E}">
-        <p14:creationId xmlns="" xmlns:p14="http://schemas.microsoft.com/office/powerpoint/2010/main" val="3521183114"/>
+        <p14:creationId xmlns:p14="http://schemas.microsoft.com/office/powerpoint/2010/main" xmlns="" val="3521183114"/>
       </p:ext>
     </p:extLst>
   </p:cSld>
@@ -1609,7 +1610,7 @@
           <p:cNvPr id="2" name="Title 1">
             <a:extLst>
               <a:ext uri="{FF2B5EF4-FFF2-40B4-BE49-F238E27FC236}">
-                <a16:creationId xmlns="" xmlns:a16="http://schemas.microsoft.com/office/drawing/2014/main" id="{5F64066D-E371-4B98-91E9-0205C29A38D5}"/>
+                <a16:creationId xmlns:a16="http://schemas.microsoft.com/office/drawing/2014/main" xmlns="" id="{5F64066D-E371-4B98-91E9-0205C29A38D5}"/>
               </a:ext>
             </a:extLst>
           </p:cNvPr>
@@ -1643,7 +1644,7 @@
           <p:cNvPr id="3" name="Text Placeholder 2">
             <a:extLst>
               <a:ext uri="{FF2B5EF4-FFF2-40B4-BE49-F238E27FC236}">
-                <a16:creationId xmlns="" xmlns:a16="http://schemas.microsoft.com/office/drawing/2014/main" id="{6D291F3E-6BB8-40EA-9642-81AC28575655}"/>
+                <a16:creationId xmlns:a16="http://schemas.microsoft.com/office/drawing/2014/main" xmlns="" id="{6D291F3E-6BB8-40EA-9642-81AC28575655}"/>
               </a:ext>
             </a:extLst>
           </p:cNvPr>
@@ -1714,7 +1715,7 @@
           <p:cNvPr id="4" name="Content Placeholder 3">
             <a:extLst>
               <a:ext uri="{FF2B5EF4-FFF2-40B4-BE49-F238E27FC236}">
-                <a16:creationId xmlns="" xmlns:a16="http://schemas.microsoft.com/office/drawing/2014/main" id="{E3D71627-C43B-41B9-93D1-AC127EDF1753}"/>
+                <a16:creationId xmlns:a16="http://schemas.microsoft.com/office/drawing/2014/main" xmlns="" id="{E3D71627-C43B-41B9-93D1-AC127EDF1753}"/>
               </a:ext>
             </a:extLst>
           </p:cNvPr>
@@ -1777,7 +1778,7 @@
           <p:cNvPr id="5" name="Text Placeholder 4">
             <a:extLst>
               <a:ext uri="{FF2B5EF4-FFF2-40B4-BE49-F238E27FC236}">
-                <a16:creationId xmlns="" xmlns:a16="http://schemas.microsoft.com/office/drawing/2014/main" id="{5729F57F-2C4A-426A-B528-A9A6B27490E3}"/>
+                <a16:creationId xmlns:a16="http://schemas.microsoft.com/office/drawing/2014/main" xmlns="" id="{5729F57F-2C4A-426A-B528-A9A6B27490E3}"/>
               </a:ext>
             </a:extLst>
           </p:cNvPr>
@@ -1848,7 +1849,7 @@
           <p:cNvPr id="6" name="Content Placeholder 5">
             <a:extLst>
               <a:ext uri="{FF2B5EF4-FFF2-40B4-BE49-F238E27FC236}">
-                <a16:creationId xmlns="" xmlns:a16="http://schemas.microsoft.com/office/drawing/2014/main" id="{108BBCD7-113F-42D8-808C-51BE80459DA2}"/>
+                <a16:creationId xmlns:a16="http://schemas.microsoft.com/office/drawing/2014/main" xmlns="" id="{108BBCD7-113F-42D8-808C-51BE80459DA2}"/>
               </a:ext>
             </a:extLst>
           </p:cNvPr>
@@ -1911,7 +1912,7 @@
           <p:cNvPr id="7" name="Date Placeholder 6">
             <a:extLst>
               <a:ext uri="{FF2B5EF4-FFF2-40B4-BE49-F238E27FC236}">
-                <a16:creationId xmlns="" xmlns:a16="http://schemas.microsoft.com/office/drawing/2014/main" id="{5F58795B-42BC-4C90-9D35-999C22D27263}"/>
+                <a16:creationId xmlns:a16="http://schemas.microsoft.com/office/drawing/2014/main" xmlns="" id="{5F58795B-42BC-4C90-9D35-999C22D27263}"/>
               </a:ext>
             </a:extLst>
           </p:cNvPr>
@@ -1941,7 +1942,7 @@
           <p:cNvPr id="8" name="Footer Placeholder 7">
             <a:extLst>
               <a:ext uri="{FF2B5EF4-FFF2-40B4-BE49-F238E27FC236}">
-                <a16:creationId xmlns="" xmlns:a16="http://schemas.microsoft.com/office/drawing/2014/main" id="{861A241B-A482-4DAF-AD71-BA7868572B34}"/>
+                <a16:creationId xmlns:a16="http://schemas.microsoft.com/office/drawing/2014/main" xmlns="" id="{861A241B-A482-4DAF-AD71-BA7868572B34}"/>
               </a:ext>
             </a:extLst>
           </p:cNvPr>
@@ -1966,7 +1967,7 @@
           <p:cNvPr id="9" name="Slide Number Placeholder 8">
             <a:extLst>
               <a:ext uri="{FF2B5EF4-FFF2-40B4-BE49-F238E27FC236}">
-                <a16:creationId xmlns="" xmlns:a16="http://schemas.microsoft.com/office/drawing/2014/main" id="{0C6BBAEC-4E21-45B9-BBFD-9985DE6368B9}"/>
+                <a16:creationId xmlns:a16="http://schemas.microsoft.com/office/drawing/2014/main" xmlns="" id="{0C6BBAEC-4E21-45B9-BBFD-9985DE6368B9}"/>
               </a:ext>
             </a:extLst>
           </p:cNvPr>
@@ -1994,7 +1995,7 @@
     </p:spTree>
     <p:extLst>
       <p:ext uri="{BB962C8B-B14F-4D97-AF65-F5344CB8AC3E}">
-        <p14:creationId xmlns="" xmlns:p14="http://schemas.microsoft.com/office/powerpoint/2010/main" val="91435806"/>
+        <p14:creationId xmlns:p14="http://schemas.microsoft.com/office/powerpoint/2010/main" xmlns="" val="91435806"/>
       </p:ext>
     </p:extLst>
   </p:cSld>
@@ -2026,7 +2027,7 @@
           <p:cNvPr id="2" name="Title 1">
             <a:extLst>
               <a:ext uri="{FF2B5EF4-FFF2-40B4-BE49-F238E27FC236}">
-                <a16:creationId xmlns="" xmlns:a16="http://schemas.microsoft.com/office/drawing/2014/main" id="{52F449E6-7ECD-49C3-BBCA-72C0674AABB4}"/>
+                <a16:creationId xmlns:a16="http://schemas.microsoft.com/office/drawing/2014/main" xmlns="" id="{52F449E6-7ECD-49C3-BBCA-72C0674AABB4}"/>
               </a:ext>
             </a:extLst>
           </p:cNvPr>
@@ -2055,7 +2056,7 @@
           <p:cNvPr id="3" name="Date Placeholder 2">
             <a:extLst>
               <a:ext uri="{FF2B5EF4-FFF2-40B4-BE49-F238E27FC236}">
-                <a16:creationId xmlns="" xmlns:a16="http://schemas.microsoft.com/office/drawing/2014/main" id="{14BF4CAD-2675-48FF-8155-9287FBE772A4}"/>
+                <a16:creationId xmlns:a16="http://schemas.microsoft.com/office/drawing/2014/main" xmlns="" id="{14BF4CAD-2675-48FF-8155-9287FBE772A4}"/>
               </a:ext>
             </a:extLst>
           </p:cNvPr>
@@ -2085,7 +2086,7 @@
           <p:cNvPr id="4" name="Footer Placeholder 3">
             <a:extLst>
               <a:ext uri="{FF2B5EF4-FFF2-40B4-BE49-F238E27FC236}">
-                <a16:creationId xmlns="" xmlns:a16="http://schemas.microsoft.com/office/drawing/2014/main" id="{8FFBF989-35FF-4401-A869-05969EAB717D}"/>
+                <a16:creationId xmlns:a16="http://schemas.microsoft.com/office/drawing/2014/main" xmlns="" id="{8FFBF989-35FF-4401-A869-05969EAB717D}"/>
               </a:ext>
             </a:extLst>
           </p:cNvPr>
@@ -2110,7 +2111,7 @@
           <p:cNvPr id="5" name="Slide Number Placeholder 4">
             <a:extLst>
               <a:ext uri="{FF2B5EF4-FFF2-40B4-BE49-F238E27FC236}">
-                <a16:creationId xmlns="" xmlns:a16="http://schemas.microsoft.com/office/drawing/2014/main" id="{EA4B274A-A165-4443-9574-895CE8597DD6}"/>
+                <a16:creationId xmlns:a16="http://schemas.microsoft.com/office/drawing/2014/main" xmlns="" id="{EA4B274A-A165-4443-9574-895CE8597DD6}"/>
               </a:ext>
             </a:extLst>
           </p:cNvPr>
@@ -2138,7 +2139,7 @@
     </p:spTree>
     <p:extLst>
       <p:ext uri="{BB962C8B-B14F-4D97-AF65-F5344CB8AC3E}">
-        <p14:creationId xmlns="" xmlns:p14="http://schemas.microsoft.com/office/powerpoint/2010/main" val="1204235255"/>
+        <p14:creationId xmlns:p14="http://schemas.microsoft.com/office/powerpoint/2010/main" xmlns="" val="1204235255"/>
       </p:ext>
     </p:extLst>
   </p:cSld>
@@ -2170,7 +2171,7 @@
           <p:cNvPr id="2" name="Date Placeholder 1">
             <a:extLst>
               <a:ext uri="{FF2B5EF4-FFF2-40B4-BE49-F238E27FC236}">
-                <a16:creationId xmlns="" xmlns:a16="http://schemas.microsoft.com/office/drawing/2014/main" id="{3636E2EB-85F6-469D-914B-2EDEB5DC10E3}"/>
+                <a16:creationId xmlns:a16="http://schemas.microsoft.com/office/drawing/2014/main" xmlns="" id="{3636E2EB-85F6-469D-914B-2EDEB5DC10E3}"/>
               </a:ext>
             </a:extLst>
           </p:cNvPr>
@@ -2200,7 +2201,7 @@
           <p:cNvPr id="3" name="Footer Placeholder 2">
             <a:extLst>
               <a:ext uri="{FF2B5EF4-FFF2-40B4-BE49-F238E27FC236}">
-                <a16:creationId xmlns="" xmlns:a16="http://schemas.microsoft.com/office/drawing/2014/main" id="{6871A4C5-FEB3-494D-8286-AFA5B25B8D9D}"/>
+                <a16:creationId xmlns:a16="http://schemas.microsoft.com/office/drawing/2014/main" xmlns="" id="{6871A4C5-FEB3-494D-8286-AFA5B25B8D9D}"/>
               </a:ext>
             </a:extLst>
           </p:cNvPr>
@@ -2225,7 +2226,7 @@
           <p:cNvPr id="4" name="Slide Number Placeholder 3">
             <a:extLst>
               <a:ext uri="{FF2B5EF4-FFF2-40B4-BE49-F238E27FC236}">
-                <a16:creationId xmlns="" xmlns:a16="http://schemas.microsoft.com/office/drawing/2014/main" id="{C7C7AE82-9387-4C55-89BB-24A45AD5059A}"/>
+                <a16:creationId xmlns:a16="http://schemas.microsoft.com/office/drawing/2014/main" xmlns="" id="{C7C7AE82-9387-4C55-89BB-24A45AD5059A}"/>
               </a:ext>
             </a:extLst>
           </p:cNvPr>
@@ -2253,7 +2254,7 @@
     </p:spTree>
     <p:extLst>
       <p:ext uri="{BB962C8B-B14F-4D97-AF65-F5344CB8AC3E}">
-        <p14:creationId xmlns="" xmlns:p14="http://schemas.microsoft.com/office/powerpoint/2010/main" val="3013825500"/>
+        <p14:creationId xmlns:p14="http://schemas.microsoft.com/office/powerpoint/2010/main" xmlns="" val="3013825500"/>
       </p:ext>
     </p:extLst>
   </p:cSld>
@@ -2285,7 +2286,7 @@
           <p:cNvPr id="2" name="Title 1">
             <a:extLst>
               <a:ext uri="{FF2B5EF4-FFF2-40B4-BE49-F238E27FC236}">
-                <a16:creationId xmlns="" xmlns:a16="http://schemas.microsoft.com/office/drawing/2014/main" id="{B23E936D-8829-4BB8-A867-54E0457C0DFA}"/>
+                <a16:creationId xmlns:a16="http://schemas.microsoft.com/office/drawing/2014/main" xmlns="" id="{B23E936D-8829-4BB8-A867-54E0457C0DFA}"/>
               </a:ext>
             </a:extLst>
           </p:cNvPr>
@@ -2323,7 +2324,7 @@
           <p:cNvPr id="3" name="Content Placeholder 2">
             <a:extLst>
               <a:ext uri="{FF2B5EF4-FFF2-40B4-BE49-F238E27FC236}">
-                <a16:creationId xmlns="" xmlns:a16="http://schemas.microsoft.com/office/drawing/2014/main" id="{88A3C72F-CEE9-48FB-9F11-D0586F2ED1AA}"/>
+                <a16:creationId xmlns:a16="http://schemas.microsoft.com/office/drawing/2014/main" xmlns="" id="{88A3C72F-CEE9-48FB-9F11-D0586F2ED1AA}"/>
               </a:ext>
             </a:extLst>
           </p:cNvPr>
@@ -2414,7 +2415,7 @@
           <p:cNvPr id="4" name="Text Placeholder 3">
             <a:extLst>
               <a:ext uri="{FF2B5EF4-FFF2-40B4-BE49-F238E27FC236}">
-                <a16:creationId xmlns="" xmlns:a16="http://schemas.microsoft.com/office/drawing/2014/main" id="{C4C40591-FB62-4D16-8640-1C1A1B5E6DE3}"/>
+                <a16:creationId xmlns:a16="http://schemas.microsoft.com/office/drawing/2014/main" xmlns="" id="{C4C40591-FB62-4D16-8640-1C1A1B5E6DE3}"/>
               </a:ext>
             </a:extLst>
           </p:cNvPr>
@@ -2485,7 +2486,7 @@
           <p:cNvPr id="5" name="Date Placeholder 4">
             <a:extLst>
               <a:ext uri="{FF2B5EF4-FFF2-40B4-BE49-F238E27FC236}">
-                <a16:creationId xmlns="" xmlns:a16="http://schemas.microsoft.com/office/drawing/2014/main" id="{E7838D76-9F15-4280-9050-14326E6BFB07}"/>
+                <a16:creationId xmlns:a16="http://schemas.microsoft.com/office/drawing/2014/main" xmlns="" id="{E7838D76-9F15-4280-9050-14326E6BFB07}"/>
               </a:ext>
             </a:extLst>
           </p:cNvPr>
@@ -2515,7 +2516,7 @@
           <p:cNvPr id="6" name="Footer Placeholder 5">
             <a:extLst>
               <a:ext uri="{FF2B5EF4-FFF2-40B4-BE49-F238E27FC236}">
-                <a16:creationId xmlns="" xmlns:a16="http://schemas.microsoft.com/office/drawing/2014/main" id="{76F20088-3883-4889-97AF-802D607B17EE}"/>
+                <a16:creationId xmlns:a16="http://schemas.microsoft.com/office/drawing/2014/main" xmlns="" id="{76F20088-3883-4889-97AF-802D607B17EE}"/>
               </a:ext>
             </a:extLst>
           </p:cNvPr>
@@ -2540,7 +2541,7 @@
           <p:cNvPr id="7" name="Slide Number Placeholder 6">
             <a:extLst>
               <a:ext uri="{FF2B5EF4-FFF2-40B4-BE49-F238E27FC236}">
-                <a16:creationId xmlns="" xmlns:a16="http://schemas.microsoft.com/office/drawing/2014/main" id="{0734916A-9F25-4A31-8882-DBF7DB057B3F}"/>
+                <a16:creationId xmlns:a16="http://schemas.microsoft.com/office/drawing/2014/main" xmlns="" id="{0734916A-9F25-4A31-8882-DBF7DB057B3F}"/>
               </a:ext>
             </a:extLst>
           </p:cNvPr>
@@ -2568,7 +2569,7 @@
     </p:spTree>
     <p:extLst>
       <p:ext uri="{BB962C8B-B14F-4D97-AF65-F5344CB8AC3E}">
-        <p14:creationId xmlns="" xmlns:p14="http://schemas.microsoft.com/office/powerpoint/2010/main" val="1882592020"/>
+        <p14:creationId xmlns:p14="http://schemas.microsoft.com/office/powerpoint/2010/main" xmlns="" val="1882592020"/>
       </p:ext>
     </p:extLst>
   </p:cSld>
@@ -2600,7 +2601,7 @@
           <p:cNvPr id="2" name="Title 1">
             <a:extLst>
               <a:ext uri="{FF2B5EF4-FFF2-40B4-BE49-F238E27FC236}">
-                <a16:creationId xmlns="" xmlns:a16="http://schemas.microsoft.com/office/drawing/2014/main" id="{9B2AB50C-175F-4F42-A189-809867FA9668}"/>
+                <a16:creationId xmlns:a16="http://schemas.microsoft.com/office/drawing/2014/main" xmlns="" id="{9B2AB50C-175F-4F42-A189-809867FA9668}"/>
               </a:ext>
             </a:extLst>
           </p:cNvPr>
@@ -2638,7 +2639,7 @@
           <p:cNvPr id="3" name="Picture Placeholder 2">
             <a:extLst>
               <a:ext uri="{FF2B5EF4-FFF2-40B4-BE49-F238E27FC236}">
-                <a16:creationId xmlns="" xmlns:a16="http://schemas.microsoft.com/office/drawing/2014/main" id="{8E890ACF-AFD2-4AB2-821E-F00C5F31A5F9}"/>
+                <a16:creationId xmlns:a16="http://schemas.microsoft.com/office/drawing/2014/main" xmlns="" id="{8E890ACF-AFD2-4AB2-821E-F00C5F31A5F9}"/>
               </a:ext>
             </a:extLst>
           </p:cNvPr>
@@ -2705,7 +2706,7 @@
           <p:cNvPr id="4" name="Text Placeholder 3">
             <a:extLst>
               <a:ext uri="{FF2B5EF4-FFF2-40B4-BE49-F238E27FC236}">
-                <a16:creationId xmlns="" xmlns:a16="http://schemas.microsoft.com/office/drawing/2014/main" id="{60043709-C786-4B05-99B9-88AEC37D9668}"/>
+                <a16:creationId xmlns:a16="http://schemas.microsoft.com/office/drawing/2014/main" xmlns="" id="{60043709-C786-4B05-99B9-88AEC37D9668}"/>
               </a:ext>
             </a:extLst>
           </p:cNvPr>
@@ -2776,7 +2777,7 @@
           <p:cNvPr id="5" name="Date Placeholder 4">
             <a:extLst>
               <a:ext uri="{FF2B5EF4-FFF2-40B4-BE49-F238E27FC236}">
-                <a16:creationId xmlns="" xmlns:a16="http://schemas.microsoft.com/office/drawing/2014/main" id="{D22D6C43-B6F1-408C-8A0F-770601C25F55}"/>
+                <a16:creationId xmlns:a16="http://schemas.microsoft.com/office/drawing/2014/main" xmlns="" id="{D22D6C43-B6F1-408C-8A0F-770601C25F55}"/>
               </a:ext>
             </a:extLst>
           </p:cNvPr>
@@ -2806,7 +2807,7 @@
           <p:cNvPr id="6" name="Footer Placeholder 5">
             <a:extLst>
               <a:ext uri="{FF2B5EF4-FFF2-40B4-BE49-F238E27FC236}">
-                <a16:creationId xmlns="" xmlns:a16="http://schemas.microsoft.com/office/drawing/2014/main" id="{0678BD1D-21CC-4DE7-BEE1-D623B02A553F}"/>
+                <a16:creationId xmlns:a16="http://schemas.microsoft.com/office/drawing/2014/main" xmlns="" id="{0678BD1D-21CC-4DE7-BEE1-D623B02A553F}"/>
               </a:ext>
             </a:extLst>
           </p:cNvPr>
@@ -2831,7 +2832,7 @@
           <p:cNvPr id="7" name="Slide Number Placeholder 6">
             <a:extLst>
               <a:ext uri="{FF2B5EF4-FFF2-40B4-BE49-F238E27FC236}">
-                <a16:creationId xmlns="" xmlns:a16="http://schemas.microsoft.com/office/drawing/2014/main" id="{FEA3AE7A-6AFE-4DC8-8036-9C9684DA8273}"/>
+                <a16:creationId xmlns:a16="http://schemas.microsoft.com/office/drawing/2014/main" xmlns="" id="{FEA3AE7A-6AFE-4DC8-8036-9C9684DA8273}"/>
               </a:ext>
             </a:extLst>
           </p:cNvPr>
@@ -2859,7 +2860,7 @@
     </p:spTree>
     <p:extLst>
       <p:ext uri="{BB962C8B-B14F-4D97-AF65-F5344CB8AC3E}">
-        <p14:creationId xmlns="" xmlns:p14="http://schemas.microsoft.com/office/powerpoint/2010/main" val="1259184627"/>
+        <p14:creationId xmlns:p14="http://schemas.microsoft.com/office/powerpoint/2010/main" xmlns="" val="1259184627"/>
       </p:ext>
     </p:extLst>
   </p:cSld>
@@ -2896,7 +2897,7 @@
           <p:cNvPr id="2" name="Title Placeholder 1">
             <a:extLst>
               <a:ext uri="{FF2B5EF4-FFF2-40B4-BE49-F238E27FC236}">
-                <a16:creationId xmlns="" xmlns:a16="http://schemas.microsoft.com/office/drawing/2014/main" id="{565E2B54-3CD0-4C6D-91BB-5B801A35BF34}"/>
+                <a16:creationId xmlns:a16="http://schemas.microsoft.com/office/drawing/2014/main" xmlns="" id="{565E2B54-3CD0-4C6D-91BB-5B801A35BF34}"/>
               </a:ext>
             </a:extLst>
           </p:cNvPr>
@@ -2935,7 +2936,7 @@
           <p:cNvPr id="3" name="Text Placeholder 2">
             <a:extLst>
               <a:ext uri="{FF2B5EF4-FFF2-40B4-BE49-F238E27FC236}">
-                <a16:creationId xmlns="" xmlns:a16="http://schemas.microsoft.com/office/drawing/2014/main" id="{7E131115-64CF-40C8-98C8-CCA45F62540A}"/>
+                <a16:creationId xmlns:a16="http://schemas.microsoft.com/office/drawing/2014/main" xmlns="" id="{7E131115-64CF-40C8-98C8-CCA45F62540A}"/>
               </a:ext>
             </a:extLst>
           </p:cNvPr>
@@ -3003,7 +3004,7 @@
           <p:cNvPr id="4" name="Date Placeholder 3">
             <a:extLst>
               <a:ext uri="{FF2B5EF4-FFF2-40B4-BE49-F238E27FC236}">
-                <a16:creationId xmlns="" xmlns:a16="http://schemas.microsoft.com/office/drawing/2014/main" id="{335DEB0A-461F-440E-B604-1DF75527DA2B}"/>
+                <a16:creationId xmlns:a16="http://schemas.microsoft.com/office/drawing/2014/main" xmlns="" id="{335DEB0A-461F-440E-B604-1DF75527DA2B}"/>
               </a:ext>
             </a:extLst>
           </p:cNvPr>
@@ -3051,7 +3052,7 @@
           <p:cNvPr id="5" name="Footer Placeholder 4">
             <a:extLst>
               <a:ext uri="{FF2B5EF4-FFF2-40B4-BE49-F238E27FC236}">
-                <a16:creationId xmlns="" xmlns:a16="http://schemas.microsoft.com/office/drawing/2014/main" id="{3A0B83EB-4DE8-4EB6-BBCA-61BE02C9F448}"/>
+                <a16:creationId xmlns:a16="http://schemas.microsoft.com/office/drawing/2014/main" xmlns="" id="{3A0B83EB-4DE8-4EB6-BBCA-61BE02C9F448}"/>
               </a:ext>
             </a:extLst>
           </p:cNvPr>
@@ -3094,7 +3095,7 @@
           <p:cNvPr id="6" name="Slide Number Placeholder 5">
             <a:extLst>
               <a:ext uri="{FF2B5EF4-FFF2-40B4-BE49-F238E27FC236}">
-                <a16:creationId xmlns="" xmlns:a16="http://schemas.microsoft.com/office/drawing/2014/main" id="{AF537C43-4A9B-4640-A015-728970869179}"/>
+                <a16:creationId xmlns:a16="http://schemas.microsoft.com/office/drawing/2014/main" xmlns="" id="{AF537C43-4A9B-4640-A015-728970869179}"/>
               </a:ext>
             </a:extLst>
           </p:cNvPr>
@@ -3140,7 +3141,7 @@
     </p:spTree>
     <p:extLst>
       <p:ext uri="{BB962C8B-B14F-4D97-AF65-F5344CB8AC3E}">
-        <p14:creationId xmlns="" xmlns:p14="http://schemas.microsoft.com/office/powerpoint/2010/main" val="3289685137"/>
+        <p14:creationId xmlns:p14="http://schemas.microsoft.com/office/powerpoint/2010/main" xmlns="" val="3289685137"/>
       </p:ext>
     </p:extLst>
   </p:cSld>
@@ -3463,7 +3464,7 @@
           <p:cNvPr id="2" name="Title 1">
             <a:extLst>
               <a:ext uri="{FF2B5EF4-FFF2-40B4-BE49-F238E27FC236}">
-                <a16:creationId xmlns="" xmlns:a16="http://schemas.microsoft.com/office/drawing/2014/main" id="{54DF952D-8CBE-44DE-B2A1-0F588A324935}"/>
+                <a16:creationId xmlns:a16="http://schemas.microsoft.com/office/drawing/2014/main" xmlns="" id="{54DF952D-8CBE-44DE-B2A1-0F588A324935}"/>
               </a:ext>
             </a:extLst>
           </p:cNvPr>
@@ -3492,7 +3493,7 @@
           <p:cNvPr id="3" name="Subtitle 2">
             <a:extLst>
               <a:ext uri="{FF2B5EF4-FFF2-40B4-BE49-F238E27FC236}">
-                <a16:creationId xmlns="" xmlns:a16="http://schemas.microsoft.com/office/drawing/2014/main" id="{1AA444F2-998C-4660-B8E0-DBD77EAC7996}"/>
+                <a16:creationId xmlns:a16="http://schemas.microsoft.com/office/drawing/2014/main" xmlns="" id="{1AA444F2-998C-4660-B8E0-DBD77EAC7996}"/>
               </a:ext>
             </a:extLst>
           </p:cNvPr>
@@ -3515,7 +3516,7 @@
     </p:spTree>
     <p:extLst>
       <p:ext uri="{BB962C8B-B14F-4D97-AF65-F5344CB8AC3E}">
-        <p14:creationId xmlns="" xmlns:p14="http://schemas.microsoft.com/office/powerpoint/2010/main" val="3032532445"/>
+        <p14:creationId xmlns:p14="http://schemas.microsoft.com/office/powerpoint/2010/main" xmlns="" val="3032532445"/>
       </p:ext>
     </p:extLst>
   </p:cSld>
@@ -3547,7 +3548,7 @@
           <p:cNvPr id="2" name="Title 1">
             <a:extLst>
               <a:ext uri="{FF2B5EF4-FFF2-40B4-BE49-F238E27FC236}">
-                <a16:creationId xmlns="" xmlns:a16="http://schemas.microsoft.com/office/drawing/2014/main" id="{8961C0A3-BC63-465F-B6DD-DC8A661193A1}"/>
+                <a16:creationId xmlns:a16="http://schemas.microsoft.com/office/drawing/2014/main" xmlns="" id="{8961C0A3-BC63-465F-B6DD-DC8A661193A1}"/>
               </a:ext>
             </a:extLst>
           </p:cNvPr>
@@ -3576,7 +3577,7 @@
           <p:cNvPr id="3" name="Content Placeholder 2">
             <a:extLst>
               <a:ext uri="{FF2B5EF4-FFF2-40B4-BE49-F238E27FC236}">
-                <a16:creationId xmlns="" xmlns:a16="http://schemas.microsoft.com/office/drawing/2014/main" id="{94779657-1A4C-475F-A0A0-2765B8EB38DE}"/>
+                <a16:creationId xmlns:a16="http://schemas.microsoft.com/office/drawing/2014/main" xmlns="" id="{94779657-1A4C-475F-A0A0-2765B8EB38DE}"/>
               </a:ext>
             </a:extLst>
           </p:cNvPr>
@@ -3791,7 +3792,7 @@
     </p:spTree>
     <p:extLst>
       <p:ext uri="{BB962C8B-B14F-4D97-AF65-F5344CB8AC3E}">
-        <p14:creationId xmlns="" xmlns:p14="http://schemas.microsoft.com/office/powerpoint/2010/main" val="4248033469"/>
+        <p14:creationId xmlns:p14="http://schemas.microsoft.com/office/powerpoint/2010/main" xmlns="" val="4248033469"/>
       </p:ext>
     </p:extLst>
   </p:cSld>
@@ -4079,7 +4080,7 @@
           <p:cNvPr id="2" name="Title 1">
             <a:extLst>
               <a:ext uri="{FF2B5EF4-FFF2-40B4-BE49-F238E27FC236}">
-                <a16:creationId xmlns="" xmlns:a16="http://schemas.microsoft.com/office/drawing/2014/main" id="{49E2218F-540B-47C2-9786-8508B41A6C42}"/>
+                <a16:creationId xmlns:a16="http://schemas.microsoft.com/office/drawing/2014/main" xmlns="" id="{49E2218F-540B-47C2-9786-8508B41A6C42}"/>
               </a:ext>
             </a:extLst>
           </p:cNvPr>
@@ -4108,7 +4109,7 @@
           <p:cNvPr id="4" name="Content Placeholder 3">
             <a:extLst>
               <a:ext uri="{FF2B5EF4-FFF2-40B4-BE49-F238E27FC236}">
-                <a16:creationId xmlns="" xmlns:a16="http://schemas.microsoft.com/office/drawing/2014/main" id="{FAD2DB17-1942-4E63-A5CC-02C3F178B165}"/>
+                <a16:creationId xmlns:a16="http://schemas.microsoft.com/office/drawing/2014/main" xmlns="" id="{FAD2DB17-1942-4E63-A5CC-02C3F178B165}"/>
               </a:ext>
             </a:extLst>
           </p:cNvPr>
@@ -4119,7 +4120,7 @@
             <p:ph idx="1"/>
             <p:extLst>
               <p:ext uri="{D42A27DB-BD31-4B8C-83A1-F6EECF244321}">
-                <p14:modId xmlns="" xmlns:p14="http://schemas.microsoft.com/office/powerpoint/2010/main" val="4023378947"/>
+                <p14:modId xmlns:p14="http://schemas.microsoft.com/office/powerpoint/2010/main" xmlns="" val="4023378947"/>
               </p:ext>
             </p:extLst>
           </p:nvPr>
@@ -4138,14 +4139,14 @@
                 <a:gridCol w="5257800">
                   <a:extLst>
                     <a:ext uri="{9D8B030D-6E8A-4147-A177-3AD203B41FA5}">
-                      <a16:colId xmlns="" xmlns:a16="http://schemas.microsoft.com/office/drawing/2014/main" val="1942258773"/>
+                      <a16:colId xmlns:a16="http://schemas.microsoft.com/office/drawing/2014/main" xmlns="" val="1942258773"/>
                     </a:ext>
                   </a:extLst>
                 </a:gridCol>
                 <a:gridCol w="5257800">
                   <a:extLst>
                     <a:ext uri="{9D8B030D-6E8A-4147-A177-3AD203B41FA5}">
-                      <a16:colId xmlns="" xmlns:a16="http://schemas.microsoft.com/office/drawing/2014/main" val="904048141"/>
+                      <a16:colId xmlns:a16="http://schemas.microsoft.com/office/drawing/2014/main" xmlns="" val="904048141"/>
                     </a:ext>
                   </a:extLst>
                 </a:gridCol>
@@ -4173,7 +4174,7 @@
                 </a:tc>
                 <a:extLst>
                   <a:ext uri="{0D108BD9-81ED-4DB2-BD59-A6C34878D82A}">
-                    <a16:rowId xmlns="" xmlns:a16="http://schemas.microsoft.com/office/drawing/2014/main" val="845308460"/>
+                    <a16:rowId xmlns:a16="http://schemas.microsoft.com/office/drawing/2014/main" xmlns="" val="845308460"/>
                   </a:ext>
                 </a:extLst>
               </a:tr>
@@ -4230,7 +4231,7 @@
                 </a:tc>
                 <a:extLst>
                   <a:ext uri="{0D108BD9-81ED-4DB2-BD59-A6C34878D82A}">
-                    <a16:rowId xmlns="" xmlns:a16="http://schemas.microsoft.com/office/drawing/2014/main" val="862806687"/>
+                    <a16:rowId xmlns:a16="http://schemas.microsoft.com/office/drawing/2014/main" xmlns="" val="862806687"/>
                   </a:ext>
                 </a:extLst>
               </a:tr>
@@ -4277,7 +4278,7 @@
                 </a:tc>
                 <a:extLst>
                   <a:ext uri="{0D108BD9-81ED-4DB2-BD59-A6C34878D82A}">
-                    <a16:rowId xmlns="" xmlns:a16="http://schemas.microsoft.com/office/drawing/2014/main" val="1166041253"/>
+                    <a16:rowId xmlns:a16="http://schemas.microsoft.com/office/drawing/2014/main" xmlns="" val="1166041253"/>
                   </a:ext>
                 </a:extLst>
               </a:tr>
@@ -4324,7 +4325,7 @@
                 </a:tc>
                 <a:extLst>
                   <a:ext uri="{0D108BD9-81ED-4DB2-BD59-A6C34878D82A}">
-                    <a16:rowId xmlns="" xmlns:a16="http://schemas.microsoft.com/office/drawing/2014/main" val="1995986874"/>
+                    <a16:rowId xmlns:a16="http://schemas.microsoft.com/office/drawing/2014/main" xmlns="" val="1995986874"/>
                   </a:ext>
                 </a:extLst>
               </a:tr>
@@ -4335,7 +4336,7 @@
     </p:spTree>
     <p:extLst>
       <p:ext uri="{BB962C8B-B14F-4D97-AF65-F5344CB8AC3E}">
-        <p14:creationId xmlns="" xmlns:p14="http://schemas.microsoft.com/office/powerpoint/2010/main" val="3819635437"/>
+        <p14:creationId xmlns:p14="http://schemas.microsoft.com/office/powerpoint/2010/main" xmlns="" val="3819635437"/>
       </p:ext>
     </p:extLst>
   </p:cSld>
@@ -4367,7 +4368,7 @@
           <p:cNvPr id="2" name="Title 1">
             <a:extLst>
               <a:ext uri="{FF2B5EF4-FFF2-40B4-BE49-F238E27FC236}">
-                <a16:creationId xmlns="" xmlns:a16="http://schemas.microsoft.com/office/drawing/2014/main" id="{53F2270C-C64A-4468-8C76-CD7C162A3E4D}"/>
+                <a16:creationId xmlns:a16="http://schemas.microsoft.com/office/drawing/2014/main" xmlns="" id="{53F2270C-C64A-4468-8C76-CD7C162A3E4D}"/>
               </a:ext>
             </a:extLst>
           </p:cNvPr>
@@ -4392,7 +4393,7 @@
           <p:cNvPr id="3" name="Content Placeholder 2">
             <a:extLst>
               <a:ext uri="{FF2B5EF4-FFF2-40B4-BE49-F238E27FC236}">
-                <a16:creationId xmlns="" xmlns:a16="http://schemas.microsoft.com/office/drawing/2014/main" id="{56F7D9D1-F7C9-431A-9F2F-D27874872FC3}"/>
+                <a16:creationId xmlns:a16="http://schemas.microsoft.com/office/drawing/2014/main" xmlns="" id="{56F7D9D1-F7C9-431A-9F2F-D27874872FC3}"/>
               </a:ext>
             </a:extLst>
           </p:cNvPr>
@@ -4425,7 +4426,7 @@
     </p:spTree>
     <p:extLst>
       <p:ext uri="{BB962C8B-B14F-4D97-AF65-F5344CB8AC3E}">
-        <p14:creationId xmlns="" xmlns:p14="http://schemas.microsoft.com/office/powerpoint/2010/main" val="345905087"/>
+        <p14:creationId xmlns:p14="http://schemas.microsoft.com/office/powerpoint/2010/main" xmlns="" val="345905087"/>
       </p:ext>
     </p:extLst>
   </p:cSld>
@@ -6719,7 +6720,7 @@
           <p:cNvPr id="2" name="Title 1">
             <a:extLst>
               <a:ext uri="{FF2B5EF4-FFF2-40B4-BE49-F238E27FC236}">
-                <a16:creationId xmlns="" xmlns:a16="http://schemas.microsoft.com/office/drawing/2014/main" id="{D03C4D14-E308-479D-B763-229C75940C83}"/>
+                <a16:creationId xmlns:a16="http://schemas.microsoft.com/office/drawing/2014/main" xmlns="" id="{D03C4D14-E308-479D-B763-229C75940C83}"/>
               </a:ext>
             </a:extLst>
           </p:cNvPr>
@@ -6748,7 +6749,7 @@
           <p:cNvPr id="3" name="Content Placeholder 2">
             <a:extLst>
               <a:ext uri="{FF2B5EF4-FFF2-40B4-BE49-F238E27FC236}">
-                <a16:creationId xmlns="" xmlns:a16="http://schemas.microsoft.com/office/drawing/2014/main" id="{523E285D-BFF9-413F-B3A7-50236E960A17}"/>
+                <a16:creationId xmlns:a16="http://schemas.microsoft.com/office/drawing/2014/main" xmlns="" id="{523E285D-BFF9-413F-B3A7-50236E960A17}"/>
               </a:ext>
             </a:extLst>
           </p:cNvPr>
@@ -6829,7 +6830,7 @@
     </p:spTree>
     <p:extLst>
       <p:ext uri="{BB962C8B-B14F-4D97-AF65-F5344CB8AC3E}">
-        <p14:creationId xmlns="" xmlns:p14="http://schemas.microsoft.com/office/powerpoint/2010/main" val="2467242464"/>
+        <p14:creationId xmlns:p14="http://schemas.microsoft.com/office/powerpoint/2010/main" xmlns="" val="2467242464"/>
       </p:ext>
     </p:extLst>
   </p:cSld>
@@ -11192,7 +11193,7 @@
           <p:cNvPr id="2" name="Title 1">
             <a:extLst>
               <a:ext uri="{FF2B5EF4-FFF2-40B4-BE49-F238E27FC236}">
-                <a16:creationId xmlns="" xmlns:a16="http://schemas.microsoft.com/office/drawing/2014/main" id="{73CE9E01-EB1A-4CB8-AC8A-A20D0D14182C}"/>
+                <a16:creationId xmlns:a16="http://schemas.microsoft.com/office/drawing/2014/main" xmlns="" id="{73CE9E01-EB1A-4CB8-AC8A-A20D0D14182C}"/>
               </a:ext>
             </a:extLst>
           </p:cNvPr>
@@ -11221,7 +11222,7 @@
           <p:cNvPr id="3" name="Content Placeholder 2">
             <a:extLst>
               <a:ext uri="{FF2B5EF4-FFF2-40B4-BE49-F238E27FC236}">
-                <a16:creationId xmlns="" xmlns:a16="http://schemas.microsoft.com/office/drawing/2014/main" id="{84D92A84-0FF1-4808-81BF-3058E2244DC5}"/>
+                <a16:creationId xmlns:a16="http://schemas.microsoft.com/office/drawing/2014/main" xmlns="" id="{84D92A84-0FF1-4808-81BF-3058E2244DC5}"/>
               </a:ext>
             </a:extLst>
           </p:cNvPr>
@@ -11308,7 +11309,7 @@
     </p:spTree>
     <p:extLst>
       <p:ext uri="{BB962C8B-B14F-4D97-AF65-F5344CB8AC3E}">
-        <p14:creationId xmlns="" xmlns:p14="http://schemas.microsoft.com/office/powerpoint/2010/main" val="774629055"/>
+        <p14:creationId xmlns:p14="http://schemas.microsoft.com/office/powerpoint/2010/main" xmlns="" val="774629055"/>
       </p:ext>
     </p:extLst>
   </p:cSld>
@@ -11855,13 +11856,8 @@
             <a:pPr lvl="1"/>
             <a:r>
               <a:rPr lang="en-SG" dirty="0" smtClean="0"/>
-              <a:t>Context</a:t>
-            </a:r>
-            <a:r>
-              <a:rPr lang="en-SG" dirty="0" smtClean="0"/>
-              <a:t>: give output of previous task</a:t>
-            </a:r>
-            <a:endParaRPr lang="en-SG" dirty="0" smtClean="0"/>
+              <a:t>Context: give output of previous task</a:t>
+            </a:r>
           </a:p>
           <a:p>
             <a:pPr lvl="1"/>
@@ -12543,7 +12539,7 @@
           <p:cNvPr id="2" name="Title 1">
             <a:extLst>
               <a:ext uri="{FF2B5EF4-FFF2-40B4-BE49-F238E27FC236}">
-                <a16:creationId xmlns="" xmlns:a16="http://schemas.microsoft.com/office/drawing/2014/main" id="{5FF0256A-0B1A-4081-911D-42235E9E03A1}"/>
+                <a16:creationId xmlns:a16="http://schemas.microsoft.com/office/drawing/2014/main" xmlns="" id="{5FF0256A-0B1A-4081-911D-42235E9E03A1}"/>
               </a:ext>
             </a:extLst>
           </p:cNvPr>
@@ -12572,7 +12568,7 @@
           <p:cNvPr id="3" name="Content Placeholder 2">
             <a:extLst>
               <a:ext uri="{FF2B5EF4-FFF2-40B4-BE49-F238E27FC236}">
-                <a16:creationId xmlns="" xmlns:a16="http://schemas.microsoft.com/office/drawing/2014/main" id="{9EAC19C5-838A-474B-A502-EABC580DB223}"/>
+                <a16:creationId xmlns:a16="http://schemas.microsoft.com/office/drawing/2014/main" xmlns="" id="{9EAC19C5-838A-474B-A502-EABC580DB223}"/>
               </a:ext>
             </a:extLst>
           </p:cNvPr>
@@ -12640,7 +12636,7 @@
     </p:spTree>
     <p:extLst>
       <p:ext uri="{BB962C8B-B14F-4D97-AF65-F5344CB8AC3E}">
-        <p14:creationId xmlns="" xmlns:p14="http://schemas.microsoft.com/office/powerpoint/2010/main" val="3491695175"/>
+        <p14:creationId xmlns:p14="http://schemas.microsoft.com/office/powerpoint/2010/main" xmlns="" val="3491695175"/>
       </p:ext>
     </p:extLst>
   </p:cSld>
@@ -14185,13 +14181,8 @@
             </a:r>
             <a:r>
               <a:rPr lang="en-US" dirty="0" smtClean="0"/>
-              <a:t>=30</a:t>
-            </a:r>
-            <a:r>
-              <a:rPr lang="en-US" dirty="0" smtClean="0"/>
-              <a:t>, (in sec)</a:t>
-            </a:r>
-            <a:endParaRPr lang="en-US" dirty="0" smtClean="0"/>
+              <a:t>=30, (in sec)</a:t>
+            </a:r>
           </a:p>
           <a:p>
             <a:r>
@@ -14288,7 +14279,7 @@
           <p:cNvPr id="2" name="Title 1">
             <a:extLst>
               <a:ext uri="{FF2B5EF4-FFF2-40B4-BE49-F238E27FC236}">
-                <a16:creationId xmlns="" xmlns:a16="http://schemas.microsoft.com/office/drawing/2014/main" id="{3B3D7ADA-595E-423D-A86D-6F06E6DECF43}"/>
+                <a16:creationId xmlns:a16="http://schemas.microsoft.com/office/drawing/2014/main" xmlns="" id="{3B3D7ADA-595E-423D-A86D-6F06E6DECF43}"/>
               </a:ext>
             </a:extLst>
           </p:cNvPr>
@@ -14317,7 +14308,7 @@
           <p:cNvPr id="3" name="Content Placeholder 2">
             <a:extLst>
               <a:ext uri="{FF2B5EF4-FFF2-40B4-BE49-F238E27FC236}">
-                <a16:creationId xmlns="" xmlns:a16="http://schemas.microsoft.com/office/drawing/2014/main" id="{781F4E2E-B83A-4464-915E-BEFF38D8A329}"/>
+                <a16:creationId xmlns:a16="http://schemas.microsoft.com/office/drawing/2014/main" xmlns="" id="{781F4E2E-B83A-4464-915E-BEFF38D8A329}"/>
               </a:ext>
             </a:extLst>
           </p:cNvPr>
@@ -14375,7 +14366,7 @@
     </p:spTree>
     <p:extLst>
       <p:ext uri="{BB962C8B-B14F-4D97-AF65-F5344CB8AC3E}">
-        <p14:creationId xmlns="" xmlns:p14="http://schemas.microsoft.com/office/powerpoint/2010/main" val="297442025"/>
+        <p14:creationId xmlns:p14="http://schemas.microsoft.com/office/powerpoint/2010/main" xmlns="" val="297442025"/>
       </p:ext>
     </p:extLst>
   </p:cSld>
@@ -15745,6 +15736,350 @@
 </p:sld>
 </file>
 
+<file path=ppt/slides/slide89.xml><?xml version="1.0" encoding="utf-8"?>
+<p:sld xmlns:a="http://schemas.openxmlformats.org/drawingml/2006/main" xmlns:r="http://schemas.openxmlformats.org/officeDocument/2006/relationships" xmlns:p="http://schemas.openxmlformats.org/presentationml/2006/main">
+  <p:cSld>
+    <p:spTree>
+      <p:nvGrpSpPr>
+        <p:cNvPr id="1" name=""/>
+        <p:cNvGrpSpPr/>
+        <p:nvPr/>
+      </p:nvGrpSpPr>
+      <p:grpSpPr>
+        <a:xfrm>
+          <a:off x="0" y="0"/>
+          <a:ext cx="0" cy="0"/>
+          <a:chOff x="0" y="0"/>
+          <a:chExt cx="0" cy="0"/>
+        </a:xfrm>
+      </p:grpSpPr>
+      <p:sp>
+        <p:nvSpPr>
+          <p:cNvPr id="2" name="Title 1"/>
+          <p:cNvSpPr>
+            <a:spLocks noGrp="1"/>
+          </p:cNvSpPr>
+          <p:nvPr>
+            <p:ph type="title"/>
+          </p:nvPr>
+        </p:nvSpPr>
+        <p:spPr/>
+        <p:txBody>
+          <a:bodyPr/>
+          <a:lstStyle/>
+          <a:p>
+            <a:r>
+              <a:rPr lang="en-SG" dirty="0" smtClean="0"/>
+              <a:t>Using </a:t>
+            </a:r>
+            <a:r>
+              <a:rPr lang="en-SG" dirty="0" err="1" smtClean="0"/>
+              <a:t>crewai</a:t>
+            </a:r>
+            <a:r>
+              <a:rPr lang="en-SG" dirty="0" smtClean="0"/>
+              <a:t> </a:t>
+            </a:r>
+            <a:r>
+              <a:rPr lang="en-SG" dirty="0" err="1" smtClean="0"/>
+              <a:t>vs</a:t>
+            </a:r>
+            <a:r>
+              <a:rPr lang="en-SG" dirty="0" smtClean="0"/>
+              <a:t> </a:t>
+            </a:r>
+            <a:r>
+              <a:rPr lang="en-SG" dirty="0" err="1" smtClean="0"/>
+              <a:t>ollama</a:t>
+            </a:r>
+            <a:r>
+              <a:rPr lang="en-SG" dirty="0" smtClean="0"/>
+              <a:t> chat app</a:t>
+            </a:r>
+            <a:endParaRPr lang="en-US" dirty="0"/>
+          </a:p>
+        </p:txBody>
+      </p:sp>
+      <p:graphicFrame>
+        <p:nvGraphicFramePr>
+          <p:cNvPr id="4" name="Content Placeholder 3"/>
+          <p:cNvGraphicFramePr>
+            <a:graphicFrameLocks noGrp="1"/>
+          </p:cNvGraphicFramePr>
+          <p:nvPr>
+            <p:ph idx="1"/>
+          </p:nvPr>
+        </p:nvGraphicFramePr>
+        <p:xfrm>
+          <a:off x="838200" y="1825625"/>
+          <a:ext cx="10515600" cy="1854200"/>
+        </p:xfrm>
+        <a:graphic>
+          <a:graphicData uri="http://schemas.openxmlformats.org/drawingml/2006/table">
+            <a:tbl>
+              <a:tblPr firstRow="1" bandRow="1">
+                <a:tableStyleId>{5C22544A-7EE6-4342-B048-85BDC9FD1C3A}</a:tableStyleId>
+              </a:tblPr>
+              <a:tblGrid>
+                <a:gridCol w="3505200"/>
+                <a:gridCol w="3505200"/>
+                <a:gridCol w="3505200"/>
+              </a:tblGrid>
+              <a:tr h="370840">
+                <a:tc>
+                  <a:txBody>
+                    <a:bodyPr/>
+                    <a:lstStyle/>
+                    <a:p>
+                      <a:endParaRPr lang="en-US" dirty="0"/>
+                    </a:p>
+                  </a:txBody>
+                  <a:tcPr/>
+                </a:tc>
+                <a:tc>
+                  <a:txBody>
+                    <a:bodyPr/>
+                    <a:lstStyle/>
+                    <a:p>
+                      <a:r>
+                        <a:rPr lang="en-SG" dirty="0" err="1" smtClean="0"/>
+                        <a:t>Crewai</a:t>
+                      </a:r>
+                      <a:endParaRPr lang="en-US" dirty="0"/>
+                    </a:p>
+                  </a:txBody>
+                  <a:tcPr/>
+                </a:tc>
+                <a:tc>
+                  <a:txBody>
+                    <a:bodyPr/>
+                    <a:lstStyle/>
+                    <a:p>
+                      <a:r>
+                        <a:rPr lang="en-SG" dirty="0" err="1" smtClean="0"/>
+                        <a:t>Ollama</a:t>
+                      </a:r>
+                      <a:r>
+                        <a:rPr lang="en-SG" dirty="0" smtClean="0"/>
+                        <a:t> chat app</a:t>
+                      </a:r>
+                      <a:endParaRPr lang="en-US" dirty="0"/>
+                    </a:p>
+                  </a:txBody>
+                  <a:tcPr/>
+                </a:tc>
+              </a:tr>
+              <a:tr h="370840">
+                <a:tc>
+                  <a:txBody>
+                    <a:bodyPr/>
+                    <a:lstStyle/>
+                    <a:p>
+                      <a:r>
+                        <a:rPr lang="en-SG" dirty="0" smtClean="0"/>
+                        <a:t>Llama4</a:t>
+                      </a:r>
+                      <a:endParaRPr lang="en-US" dirty="0"/>
+                    </a:p>
+                  </a:txBody>
+                  <a:tcPr/>
+                </a:tc>
+                <a:tc>
+                  <a:txBody>
+                    <a:bodyPr/>
+                    <a:lstStyle/>
+                    <a:p>
+                      <a:r>
+                        <a:rPr lang="en-SG" dirty="0" smtClean="0"/>
+                        <a:t>Wrong code, wrong answer</a:t>
+                      </a:r>
+                      <a:endParaRPr lang="en-US" dirty="0"/>
+                    </a:p>
+                  </a:txBody>
+                  <a:tcPr/>
+                </a:tc>
+                <a:tc>
+                  <a:txBody>
+                    <a:bodyPr/>
+                    <a:lstStyle/>
+                    <a:p>
+                      <a:r>
+                        <a:rPr lang="en-SG" dirty="0" smtClean="0"/>
+                        <a:t>Correct answer</a:t>
+                      </a:r>
+                      <a:endParaRPr lang="en-US" dirty="0"/>
+                    </a:p>
+                  </a:txBody>
+                  <a:tcPr/>
+                </a:tc>
+              </a:tr>
+              <a:tr h="370840">
+                <a:tc>
+                  <a:txBody>
+                    <a:bodyPr/>
+                    <a:lstStyle/>
+                    <a:p>
+                      <a:r>
+                        <a:rPr lang="en-SG" dirty="0" smtClean="0"/>
+                        <a:t>Llama3.1</a:t>
+                      </a:r>
+                      <a:endParaRPr lang="en-US" dirty="0"/>
+                    </a:p>
+                  </a:txBody>
+                  <a:tcPr/>
+                </a:tc>
+                <a:tc>
+                  <a:txBody>
+                    <a:bodyPr/>
+                    <a:lstStyle/>
+                    <a:p>
+                      <a:endParaRPr lang="en-US" dirty="0"/>
+                    </a:p>
+                  </a:txBody>
+                  <a:tcPr/>
+                </a:tc>
+                <a:tc>
+                  <a:txBody>
+                    <a:bodyPr/>
+                    <a:lstStyle/>
+                    <a:p>
+                      <a:r>
+                        <a:rPr lang="en-SG" dirty="0" smtClean="0"/>
+                        <a:t>Correct answer</a:t>
+                      </a:r>
+                      <a:endParaRPr lang="en-US" dirty="0"/>
+                    </a:p>
+                  </a:txBody>
+                  <a:tcPr/>
+                </a:tc>
+              </a:tr>
+              <a:tr h="370840">
+                <a:tc>
+                  <a:txBody>
+                    <a:bodyPr/>
+                    <a:lstStyle/>
+                    <a:p>
+                      <a:r>
+                        <a:rPr lang="en-SG" dirty="0" smtClean="0"/>
+                        <a:t>Gpt-oss:20b</a:t>
+                      </a:r>
+                      <a:endParaRPr lang="en-US" dirty="0"/>
+                    </a:p>
+                  </a:txBody>
+                  <a:tcPr/>
+                </a:tc>
+                <a:tc>
+                  <a:txBody>
+                    <a:bodyPr/>
+                    <a:lstStyle/>
+                    <a:p>
+                      <a:endParaRPr lang="en-US" dirty="0"/>
+                    </a:p>
+                  </a:txBody>
+                  <a:tcPr/>
+                </a:tc>
+                <a:tc>
+                  <a:txBody>
+                    <a:bodyPr/>
+                    <a:lstStyle/>
+                    <a:p>
+                      <a:endParaRPr lang="en-US" dirty="0"/>
+                    </a:p>
+                  </a:txBody>
+                  <a:tcPr/>
+                </a:tc>
+              </a:tr>
+              <a:tr h="370840">
+                <a:tc>
+                  <a:txBody>
+                    <a:bodyPr/>
+                    <a:lstStyle/>
+                    <a:p>
+                      <a:endParaRPr lang="en-US" dirty="0"/>
+                    </a:p>
+                  </a:txBody>
+                  <a:tcPr/>
+                </a:tc>
+                <a:tc>
+                  <a:txBody>
+                    <a:bodyPr/>
+                    <a:lstStyle/>
+                    <a:p>
+                      <a:endParaRPr lang="en-US" dirty="0"/>
+                    </a:p>
+                  </a:txBody>
+                  <a:tcPr/>
+                </a:tc>
+                <a:tc>
+                  <a:txBody>
+                    <a:bodyPr/>
+                    <a:lstStyle/>
+                    <a:p>
+                      <a:endParaRPr lang="en-US" dirty="0"/>
+                    </a:p>
+                  </a:txBody>
+                  <a:tcPr/>
+                </a:tc>
+              </a:tr>
+            </a:tbl>
+          </a:graphicData>
+        </a:graphic>
+      </p:graphicFrame>
+      <p:sp>
+        <p:nvSpPr>
+          <p:cNvPr id="5" name="TextBox 4"/>
+          <p:cNvSpPr txBox="1"/>
+          <p:nvPr/>
+        </p:nvSpPr>
+        <p:spPr>
+          <a:xfrm>
+            <a:off x="914400" y="4438650"/>
+            <a:ext cx="10596812" cy="923330"/>
+          </a:xfrm>
+          <a:prstGeom prst="rect">
+            <a:avLst/>
+          </a:prstGeom>
+          <a:noFill/>
+        </p:spPr>
+        <p:txBody>
+          <a:bodyPr wrap="none" rtlCol="0">
+            <a:spAutoFit/>
+          </a:bodyPr>
+          <a:lstStyle/>
+          <a:p>
+            <a:r>
+              <a:rPr lang="en-SG" dirty="0" smtClean="0"/>
+              <a:t>Using </a:t>
+            </a:r>
+            <a:r>
+              <a:rPr lang="en-SG" dirty="0" err="1" smtClean="0"/>
+              <a:t>agentic</a:t>
+            </a:r>
+            <a:r>
+              <a:rPr lang="en-SG" dirty="0" smtClean="0"/>
+              <a:t> framework makes the model performs poorer. Maybe due to orchestration, making it more noisy.</a:t>
+            </a:r>
+          </a:p>
+          <a:p>
+            <a:endParaRPr lang="en-SG" dirty="0" smtClean="0"/>
+          </a:p>
+          <a:p>
+            <a:r>
+              <a:rPr lang="en-SG" dirty="0" smtClean="0"/>
+              <a:t>Qwen3.6 takes very long to think (very nagging)</a:t>
+            </a:r>
+            <a:endParaRPr lang="en-US" dirty="0"/>
+          </a:p>
+        </p:txBody>
+      </p:sp>
+    </p:spTree>
+  </p:cSld>
+  <p:clrMapOvr>
+    <a:masterClrMapping/>
+  </p:clrMapOvr>
+</p:sld>
+</file>
+
 <file path=ppt/slides/slide9.xml><?xml version="1.0" encoding="utf-8"?>
 <p:sld xmlns:a="http://schemas.openxmlformats.org/drawingml/2006/main" xmlns:r="http://schemas.openxmlformats.org/officeDocument/2006/relationships" xmlns:p="http://schemas.openxmlformats.org/presentationml/2006/main">
   <p:cSld>
@@ -15767,7 +16102,7 @@
           <p:cNvPr id="2" name="Title 1">
             <a:extLst>
               <a:ext uri="{FF2B5EF4-FFF2-40B4-BE49-F238E27FC236}">
-                <a16:creationId xmlns="" xmlns:a16="http://schemas.microsoft.com/office/drawing/2014/main" id="{6045983A-AE9C-4F80-BAD5-C87458E8EF08}"/>
+                <a16:creationId xmlns:a16="http://schemas.microsoft.com/office/drawing/2014/main" xmlns="" id="{6045983A-AE9C-4F80-BAD5-C87458E8EF08}"/>
               </a:ext>
             </a:extLst>
           </p:cNvPr>
@@ -15800,7 +16135,7 @@
           <p:cNvPr id="3" name="Content Placeholder 2">
             <a:extLst>
               <a:ext uri="{FF2B5EF4-FFF2-40B4-BE49-F238E27FC236}">
-                <a16:creationId xmlns="" xmlns:a16="http://schemas.microsoft.com/office/drawing/2014/main" id="{CCC6298C-5613-4B3B-B4DF-1038AEFB409D}"/>
+                <a16:creationId xmlns:a16="http://schemas.microsoft.com/office/drawing/2014/main" xmlns="" id="{CCC6298C-5613-4B3B-B4DF-1038AEFB409D}"/>
               </a:ext>
             </a:extLst>
           </p:cNvPr>
@@ -15879,7 +16214,7 @@
     </p:spTree>
     <p:extLst>
       <p:ext uri="{BB962C8B-B14F-4D97-AF65-F5344CB8AC3E}">
-        <p14:creationId xmlns="" xmlns:p14="http://schemas.microsoft.com/office/powerpoint/2010/main" val="1011639427"/>
+        <p14:creationId xmlns:p14="http://schemas.microsoft.com/office/powerpoint/2010/main" xmlns="" val="1011639427"/>
       </p:ext>
     </p:extLst>
   </p:cSld>
@@ -16178,7 +16513,7 @@
   <a:extraClrSchemeLst/>
   <a:extLst>
     <a:ext uri="{05A4C25C-085E-4340-85A3-A5531E510DB2}">
-      <thm15:themeFamily xmlns="" xmlns:thm15="http://schemas.microsoft.com/office/thememl/2012/main" name="Office Theme" id="{62F939B6-93AF-4DB8-9C6B-D6C7DFDC589F}" vid="{4A3C46E8-61CC-4603-A589-7422A47A8E4A}"/>
+      <thm15:themeFamily xmlns:thm15="http://schemas.microsoft.com/office/thememl/2012/main" xmlns="" name="Office Theme" id="{62F939B6-93AF-4DB8-9C6B-D6C7DFDC589F}" vid="{4A3C46E8-61CC-4603-A589-7422A47A8E4A}"/>
     </a:ext>
   </a:extLst>
 </a:theme>

</xml_diff>